<commit_message>
Fase 2: diario de reflexion y correccion del conteo de actividades
</commit_message>
<xml_diff>
--- a/Fase 2/Evidencias Grupales/Presentacion Proyecto.pptx
+++ b/Fase 2/Evidencias Grupales/Presentacion Proyecto.pptx
@@ -7095,7 +7095,7 @@
                 <a:cs typeface="DM Sans"/>
                 <a:sym typeface="DM Sans"/>
               </a:rPr>
-              <a:t>•  Once actividades completadas, dos en curso y tres por iniciar.</a:t>
+              <a:t>•  Diez actividades completadas, dos en curso y dos por iniciar.</a:t>
             </a:r>
           </a:p>
           <a:p>
@@ -7114,7 +7114,7 @@
                 <a:cs typeface="DM Sans"/>
                 <a:sym typeface="DM Sans"/>
               </a:rPr>
-              <a:t>•  Ninguna actividad está atrasada: las tres pendientes siguen dentro de su plazo original.</a:t>
+              <a:t>•  Ninguna actividad está atrasada: las pendientes siguen dentro de su plazo original.</a:t>
             </a:r>
           </a:p>
           <a:p>

</xml_diff>